<commit_message>
docs(slides): make the demo slide match the demo that works
The demo slide said that a laptop takes the macOS leg, but no Mac node
is online. What works today is the Linux leg on the team machine
ces.pubcom.org: it takes the leg over Logos Delivery, runs the full
test suite and streams the log back. The slide now shows that run,
started with Re-run all jobs.
</commit_message>
<xml_diff>
--- a/slides/octopus.pptx
+++ b/slides/octopus.pptx
@@ -6314,7 +6314,7 @@
                 </a:solidFill>
                 <a:latin typeface="DejaVu Sans Mono"/>
               </a:rPr>
-              <a:t>octopus ci status</a:t>
+              <a:t>Re-run all jobs</a:t>
             </a:r>
           </a:p>
         </p:txBody>
@@ -6353,7 +6353,7 @@
                 </a:solidFill>
                 <a:latin typeface="DejaVu Sans"/>
               </a:rPr>
-              <a:t>this laptop's proof, team key and allowlist — its only setup</a:t>
+              <a:t>a fresh CI run of this repo starts on GitHub</a:t>
             </a:r>
           </a:p>
         </p:txBody>
@@ -6446,7 +6446,7 @@
                 </a:solidFill>
                 <a:latin typeface="DejaVu Sans Mono"/>
               </a:rPr>
-              <a:t>git push</a:t>
+              <a:t>submit job joins the fleet</a:t>
             </a:r>
           </a:p>
         </p:txBody>
@@ -6485,7 +6485,7 @@
                 </a:solidFill>
                 <a:latin typeface="DejaVu Sans"/>
               </a:rPr>
-              <a:t>a one-line change starts the workflow on GitHub</a:t>
+              <a:t>publishes one request per leg on Logos Delivery</a:t>
             </a:r>
           </a:p>
         </p:txBody>
@@ -6578,7 +6578,7 @@
                 </a:solidFill>
                 <a:latin typeface="DejaVu Sans Mono"/>
               </a:rPr>
-              <a:t>submit job joins the fleet</a:t>
+              <a:t>linux: taken by node …</a:t>
             </a:r>
           </a:p>
         </p:txBody>
@@ -6617,7 +6617,7 @@
                 </a:solidFill>
                 <a:latin typeface="DejaVu Sans"/>
               </a:rPr>
-              <a:t>publishes one request per leg on Logos Delivery</a:t>
+              <a:t>our Linux team machine claims the leg</a:t>
             </a:r>
           </a:p>
         </p:txBody>
@@ -6710,7 +6710,7 @@
                 </a:solidFill>
                 <a:latin typeface="DejaVu Sans Mono"/>
               </a:rPr>
-              <a:t>CI leg started …</a:t>
+              <a:t>[linux] …</a:t>
             </a:r>
           </a:p>
         </p:txBody>
@@ -6749,7 +6749,7 @@
                 </a:solidFill>
                 <a:latin typeface="DejaVu Sans"/>
               </a:rPr>
-              <a:t>the laptop claims the macOS leg and runs .octopus/ci.sh</a:t>
+              <a:t>the test output streams back over Logos Delivery</a:t>
             </a:r>
           </a:p>
         </p:txBody>
@@ -6842,7 +6842,7 @@
                 </a:solidFill>
                 <a:latin typeface="DejaVu Sans Mono"/>
               </a:rPr>
-              <a:t>[macos] …</a:t>
+              <a:t>995 passed</a:t>
             </a:r>
           </a:p>
         </p:txBody>
@@ -6881,7 +6881,7 @@
                 </a:solidFill>
                 <a:latin typeface="DejaVu Sans"/>
               </a:rPr>
-              <a:t>its output streams live into the GitHub Actions log</a:t>
+              <a:t>the full test suite ran on the team machine</a:t>
             </a:r>
           </a:p>
         </p:txBody>
@@ -7013,7 +7013,7 @@
                 </a:solidFill>
                 <a:latin typeface="DejaVu Sans"/>
               </a:rPr>
-              <a:t>macOS: this laptop · Linux: server node or hosted · Windows: hosted</a:t>
+              <a:t>Linux: team machine · macOS, Windows: GitHub-hosted fallback</a:t>
             </a:r>
           </a:p>
         </p:txBody>

</xml_diff>

<commit_message>
docs(slides): the demo slide works with either team machine
Last night the Linux server stopped taking legs for a while (its bot
account fell off the team list, fixed in #125), and Ivan's Mac took the
macOS legs. The demo slide now says "a team machine (our server or
Ivan's Mac)" and starts from a finished run or a re-run, so it is true
whichever machine is online.
</commit_message>
<xml_diff>
--- a/slides/octopus.pptx
+++ b/slides/octopus.pptx
@@ -6314,7 +6314,7 @@
                 </a:solidFill>
                 <a:latin typeface="DejaVu Sans Mono"/>
               </a:rPr>
-              <a:t>Re-run all jobs</a:t>
+              <a:t>a CI run of this repo</a:t>
             </a:r>
           </a:p>
         </p:txBody>
@@ -6353,7 +6353,7 @@
                 </a:solidFill>
                 <a:latin typeface="DejaVu Sans"/>
               </a:rPr>
-              <a:t>a fresh CI run of this repo starts on GitHub</a:t>
+              <a:t>a finished run, or Re-run all jobs on GitHub</a:t>
             </a:r>
           </a:p>
         </p:txBody>
@@ -6578,7 +6578,7 @@
                 </a:solidFill>
                 <a:latin typeface="DejaVu Sans Mono"/>
               </a:rPr>
-              <a:t>linux: taken by node …</a:t>
+              <a:t>taken by node …</a:t>
             </a:r>
           </a:p>
         </p:txBody>
@@ -6617,7 +6617,7 @@
                 </a:solidFill>
                 <a:latin typeface="DejaVu Sans"/>
               </a:rPr>
-              <a:t>our Linux team machine claims the leg</a:t>
+              <a:t>a team machine (our server or Ivan's Mac) claims a leg</a:t>
             </a:r>
           </a:p>
         </p:txBody>
@@ -6710,7 +6710,7 @@
                 </a:solidFill>
                 <a:latin typeface="DejaVu Sans Mono"/>
               </a:rPr>
-              <a:t>[linux] …</a:t>
+              <a:t>[linux] / [macos] …</a:t>
             </a:r>
           </a:p>
         </p:txBody>
@@ -7013,7 +7013,7 @@
                 </a:solidFill>
                 <a:latin typeface="DejaVu Sans"/>
               </a:rPr>
-              <a:t>Linux: team machine · macOS, Windows: GitHub-hosted fallback</a:t>
+              <a:t>each leg: a team machine, or the GitHub-hosted fallback</a:t>
             </a:r>
           </a:p>
         </p:txBody>

</xml_diff>